<commit_message>
Trifold for farmers: final copy; Why Biology flap rebuilt with the new last paragraph
Body 3 cut, the chemically-managed-land paragraph added, the Our story box
in the paragraphs' own type and spacing. Print PDF, PowerPoint and copy
file rebuilt; all five codes scan in the print file.

Co-Authored-By: Claude Opus 5.5 <noreply@anthropic.com>
Claude-Session: https://claude.ai/code/session_01Two6wTBX3BHPyNb7hsdtRq
</commit_message>
<xml_diff>
--- a/trifold-farmers/sfw-farmers-trifold-editable.pptx
+++ b/trifold-farmers/sfw-farmers-trifold-editable.pptx
@@ -3400,7 +3400,7 @@
         <p:spPr>
           <a:xfrm>
             <a:off x="255984" y="2488704"/>
-            <a:ext cx="2788134" cy="788045"/>
+            <a:ext cx="2788134" cy="770930"/>
           </a:xfrm>
           <a:prstGeom prst="rect">
             <a:avLst/>
@@ -3415,7 +3415,7 @@
           <a:p>
             <a:pPr algn="l">
               <a:lnSpc>
-                <a:spcPts val="1241"/>
+                <a:spcPts val="1214"/>
               </a:lnSpc>
             </a:pPr>
             <a:r>
@@ -3438,8 +3438,8 @@
         </p:nvSpPr>
         <p:spPr>
           <a:xfrm>
-            <a:off x="255984" y="3331518"/>
-            <a:ext cx="2788134" cy="788045"/>
+            <a:off x="255984" y="3314402"/>
+            <a:ext cx="2788134" cy="616744"/>
           </a:xfrm>
           <a:prstGeom prst="rect">
             <a:avLst/>
@@ -3454,7 +3454,7 @@
           <a:p>
             <a:pPr algn="l">
               <a:lnSpc>
-                <a:spcPts val="1241"/>
+                <a:spcPts val="1214"/>
               </a:lnSpc>
             </a:pPr>
             <a:r>
@@ -3477,8 +3477,8 @@
         </p:nvSpPr>
         <p:spPr>
           <a:xfrm>
-            <a:off x="255984" y="4174331"/>
-            <a:ext cx="2788134" cy="315218"/>
+            <a:off x="255984" y="3985915"/>
+            <a:ext cx="2788134" cy="462558"/>
           </a:xfrm>
           <a:prstGeom prst="rect">
             <a:avLst/>
@@ -3493,7 +3493,7 @@
           <a:p>
             <a:pPr algn="l">
               <a:lnSpc>
-                <a:spcPts val="1241"/>
+                <a:spcPts val="1214"/>
               </a:lnSpc>
             </a:pPr>
             <a:r>
@@ -3503,7 +3503,7 @@
                 </a:solidFill>
                 <a:latin typeface="Source Sans 3"/>
               </a:rPr>
-              <a:t>A surface already inhabited leaves little room for invaders.</a:t>
+              <a:t>These microbes are often lost in land that has been chemically managed or compacted. Biologically complete compost is designed to restore them.</a:t>
             </a:r>
           </a:p>
         </p:txBody>
@@ -3516,12 +3516,12 @@
         </p:nvSpPr>
         <p:spPr>
           <a:xfrm>
-            <a:off x="255984" y="4631085"/>
-            <a:ext cx="2688431" cy="958751"/>
+            <a:off x="255984" y="4558010"/>
+            <a:ext cx="2688431" cy="1001316"/>
           </a:xfrm>
           <a:prstGeom prst="roundRect">
             <a:avLst>
-              <a:gd name="adj" fmla="val 4291"/>
+              <a:gd name="adj" fmla="val 4109"/>
             </a:avLst>
           </a:prstGeom>
           <a:solidFill>
@@ -3564,8 +3564,8 @@
         </p:nvSpPr>
         <p:spPr>
           <a:xfrm>
-            <a:off x="255984" y="4631085"/>
-            <a:ext cx="19050" cy="958751"/>
+            <a:off x="255984" y="4558010"/>
+            <a:ext cx="19050" cy="1001316"/>
           </a:xfrm>
           <a:prstGeom prst="rect">
             <a:avLst/>
@@ -3610,8 +3610,8 @@
         </p:nvSpPr>
         <p:spPr>
           <a:xfrm>
-            <a:off x="393799" y="4740771"/>
-            <a:ext cx="2523857" cy="739378"/>
+            <a:off x="393799" y="4667696"/>
+            <a:ext cx="2523857" cy="781943"/>
           </a:xfrm>
           <a:prstGeom prst="rect">
             <a:avLst/>
@@ -3626,7 +3626,7 @@
           <a:p>
             <a:pPr algn="l">
               <a:lnSpc>
-                <a:spcPts val="1148"/>
+                <a:spcPts val="1214"/>
               </a:lnSpc>
             </a:pPr>
             <a:r>
@@ -3642,7 +3642,7 @@
           <a:p>
             <a:pPr algn="l">
               <a:lnSpc>
-                <a:spcPts val="1148"/>
+                <a:spcPts val="1214"/>
               </a:lnSpc>
             </a:pPr>
             <a:r>
@@ -3673,7 +3673,7 @@
         </p:blipFill>
         <p:spPr>
           <a:xfrm>
-            <a:off x="255984" y="5676602"/>
+            <a:off x="255984" y="5646093"/>
             <a:ext cx="1078855" cy="658267"/>
           </a:xfrm>
           <a:prstGeom prst="rect">
@@ -3689,7 +3689,7 @@
         </p:nvSpPr>
         <p:spPr>
           <a:xfrm>
-            <a:off x="1453604" y="5867995"/>
+            <a:off x="1453604" y="5837486"/>
             <a:ext cx="1480852" cy="220712"/>
           </a:xfrm>
           <a:prstGeom prst="rect">

</xml_diff>

<commit_message>
Editable PowerPoint of the first trifold, every element separate
Same exporter as the farmers file, pointed at Trifold Design/build; the
first trifold's own files are untouched. Inline icons now indent their
text, and text boxes carry a little more measure so Canva does not wrap
early. Farmers README brought up to date.

Co-Authored-By: Claude Opus 5.5 <noreply@anthropic.com>
Claude-Session: https://claude.ai/code/session_01Two6wTBX3BHPyNb7hsdtRq
</commit_message>
<xml_diff>
--- a/trifold-farmers/sfw-farmers-trifold-editable.pptx
+++ b/trifold-farmers/sfw-farmers-trifold-editable.pptx
@@ -3192,7 +3192,7 @@
         <p:spPr>
           <a:xfrm>
             <a:off x="255984" y="260152"/>
-            <a:ext cx="2788134" cy="112068"/>
+            <a:ext cx="2878312" cy="112068"/>
           </a:xfrm>
           <a:prstGeom prst="rect">
             <a:avLst/>
@@ -3233,7 +3233,7 @@
         <p:spPr>
           <a:xfrm>
             <a:off x="255984" y="422374"/>
-            <a:ext cx="2788134" cy="373261"/>
+            <a:ext cx="2878312" cy="373261"/>
           </a:xfrm>
           <a:prstGeom prst="rect">
             <a:avLst/>
@@ -3320,7 +3320,7 @@
         <p:spPr>
           <a:xfrm>
             <a:off x="237679" y="2025253"/>
-            <a:ext cx="2806989" cy="107156"/>
+            <a:ext cx="2897716" cy="107156"/>
           </a:xfrm>
           <a:prstGeom prst="rect">
             <a:avLst/>
@@ -3361,7 +3361,7 @@
         <p:spPr>
           <a:xfrm>
             <a:off x="255984" y="2328714"/>
-            <a:ext cx="2788134" cy="127992"/>
+            <a:ext cx="2878312" cy="127992"/>
           </a:xfrm>
           <a:prstGeom prst="rect">
             <a:avLst/>
@@ -3400,7 +3400,7 @@
         <p:spPr>
           <a:xfrm>
             <a:off x="255984" y="2488704"/>
-            <a:ext cx="2788134" cy="770930"/>
+            <a:ext cx="2878312" cy="770930"/>
           </a:xfrm>
           <a:prstGeom prst="rect">
             <a:avLst/>
@@ -3439,7 +3439,7 @@
         <p:spPr>
           <a:xfrm>
             <a:off x="255984" y="3314402"/>
-            <a:ext cx="2788134" cy="616744"/>
+            <a:ext cx="2878312" cy="616744"/>
           </a:xfrm>
           <a:prstGeom prst="rect">
             <a:avLst/>
@@ -3478,7 +3478,7 @@
         <p:spPr>
           <a:xfrm>
             <a:off x="255984" y="3985915"/>
-            <a:ext cx="2788134" cy="462558"/>
+            <a:ext cx="2878312" cy="462558"/>
           </a:xfrm>
           <a:prstGeom prst="rect">
             <a:avLst/>
@@ -3611,7 +3611,7 @@
         <p:spPr>
           <a:xfrm>
             <a:off x="393799" y="4667696"/>
-            <a:ext cx="2523857" cy="781943"/>
+            <a:ext cx="2606338" cy="781943"/>
           </a:xfrm>
           <a:prstGeom prst="rect">
             <a:avLst/>
@@ -3690,7 +3690,7 @@
         <p:spPr>
           <a:xfrm>
             <a:off x="1453604" y="5837486"/>
-            <a:ext cx="1480852" cy="220712"/>
+            <a:ext cx="1532954" cy="220712"/>
           </a:xfrm>
           <a:prstGeom prst="rect">
             <a:avLst/>
@@ -3771,7 +3771,7 @@
         <p:spPr>
           <a:xfrm>
             <a:off x="1417141" y="6650980"/>
-            <a:ext cx="1592142" cy="132457"/>
+            <a:ext cx="1647486" cy="132457"/>
           </a:xfrm>
           <a:prstGeom prst="rect">
             <a:avLst/>
@@ -3810,7 +3810,7 @@
         <p:spPr>
           <a:xfrm>
             <a:off x="1417141" y="6815435"/>
-            <a:ext cx="1592142" cy="360313"/>
+            <a:ext cx="1647486" cy="360313"/>
           </a:xfrm>
           <a:prstGeom prst="rect">
             <a:avLst/>
@@ -3851,7 +3851,7 @@
         <p:spPr>
           <a:xfrm>
             <a:off x="1417141" y="7207746"/>
-            <a:ext cx="1592142" cy="122486"/>
+            <a:ext cx="1647486" cy="122486"/>
           </a:xfrm>
           <a:prstGeom prst="rect">
             <a:avLst/>
@@ -3988,7 +3988,7 @@
         <p:spPr>
           <a:xfrm>
             <a:off x="3456384" y="260152"/>
-            <a:ext cx="3023592" cy="112068"/>
+            <a:ext cx="3120628" cy="112068"/>
           </a:xfrm>
           <a:prstGeom prst="rect">
             <a:avLst/>
@@ -4029,7 +4029,7 @@
         <p:spPr>
           <a:xfrm>
             <a:off x="3456384" y="422374"/>
-            <a:ext cx="3023592" cy="373261"/>
+            <a:ext cx="3120628" cy="373261"/>
           </a:xfrm>
           <a:prstGeom prst="rect">
             <a:avLst/>
@@ -4092,7 +4092,7 @@
         <p:spPr>
           <a:xfrm>
             <a:off x="3456384" y="2025253"/>
-            <a:ext cx="3023592" cy="107156"/>
+            <a:ext cx="3120628" cy="107156"/>
           </a:xfrm>
           <a:prstGeom prst="rect">
             <a:avLst/>
@@ -4131,7 +4131,7 @@
         <p:spPr>
           <a:xfrm>
             <a:off x="3456384" y="2328714"/>
-            <a:ext cx="3023592" cy="255984"/>
+            <a:ext cx="3120628" cy="255984"/>
           </a:xfrm>
           <a:prstGeom prst="rect">
             <a:avLst/>
@@ -4170,7 +4170,7 @@
         <p:spPr>
           <a:xfrm>
             <a:off x="3456384" y="2616696"/>
-            <a:ext cx="3023592" cy="883146"/>
+            <a:ext cx="3120628" cy="883146"/>
           </a:xfrm>
           <a:prstGeom prst="rect">
             <a:avLst/>
@@ -4233,7 +4233,7 @@
         <p:spPr>
           <a:xfrm>
             <a:off x="4617541" y="3641378"/>
-            <a:ext cx="1827600" cy="264914"/>
+            <a:ext cx="1889802" cy="264914"/>
           </a:xfrm>
           <a:prstGeom prst="rect">
             <a:avLst/>
@@ -4272,7 +4272,7 @@
         <p:spPr>
           <a:xfrm>
             <a:off x="4617541" y="3938290"/>
-            <a:ext cx="1827600" cy="600521"/>
+            <a:ext cx="1889802" cy="600521"/>
           </a:xfrm>
           <a:prstGeom prst="rect">
             <a:avLst/>
@@ -4311,7 +4311,7 @@
         <p:spPr>
           <a:xfrm>
             <a:off x="4617541" y="4570809"/>
-            <a:ext cx="1827600" cy="122486"/>
+            <a:ext cx="1889802" cy="122486"/>
           </a:xfrm>
           <a:prstGeom prst="rect">
             <a:avLst/>
@@ -4374,7 +4374,7 @@
         <p:spPr>
           <a:xfrm>
             <a:off x="3456384" y="5063430"/>
-            <a:ext cx="699671" cy="91232"/>
+            <a:ext cx="729020" cy="91232"/>
           </a:xfrm>
           <a:prstGeom prst="rect">
             <a:avLst/>
@@ -4437,7 +4437,7 @@
         <p:spPr>
           <a:xfrm>
             <a:off x="4208562" y="5063430"/>
-            <a:ext cx="699671" cy="91232"/>
+            <a:ext cx="729020" cy="91232"/>
           </a:xfrm>
           <a:prstGeom prst="rect">
             <a:avLst/>
@@ -4500,7 +4500,7 @@
         <p:spPr>
           <a:xfrm>
             <a:off x="4960739" y="5063430"/>
-            <a:ext cx="699671" cy="91232"/>
+            <a:ext cx="729020" cy="91232"/>
           </a:xfrm>
           <a:prstGeom prst="rect">
             <a:avLst/>
@@ -4563,7 +4563,7 @@
         <p:spPr>
           <a:xfrm>
             <a:off x="5712916" y="5063430"/>
-            <a:ext cx="699671" cy="91232"/>
+            <a:ext cx="729020" cy="91232"/>
           </a:xfrm>
           <a:prstGeom prst="rect">
             <a:avLst/>
@@ -4748,7 +4748,7 @@
         <p:spPr>
           <a:xfrm>
             <a:off x="3594199" y="5451425"/>
-            <a:ext cx="2759315" cy="125462"/>
+            <a:ext cx="2848654" cy="125462"/>
           </a:xfrm>
           <a:prstGeom prst="rect">
             <a:avLst/>
@@ -4787,7 +4787,7 @@
         <p:spPr>
           <a:xfrm>
             <a:off x="3594199" y="5617964"/>
-            <a:ext cx="2759315" cy="376386"/>
+            <a:ext cx="2848654" cy="376386"/>
           </a:xfrm>
           <a:prstGeom prst="rect">
             <a:avLst/>
@@ -4858,7 +4858,7 @@
         <p:spPr>
           <a:xfrm>
             <a:off x="3594199" y="6035427"/>
-            <a:ext cx="2759315" cy="233065"/>
+            <a:ext cx="2848654" cy="233065"/>
           </a:xfrm>
           <a:prstGeom prst="rect">
             <a:avLst/>
@@ -4945,7 +4945,7 @@
         <p:spPr>
           <a:xfrm>
             <a:off x="4617541" y="6650980"/>
-            <a:ext cx="1827600" cy="132457"/>
+            <a:ext cx="1889802" cy="132457"/>
           </a:xfrm>
           <a:prstGeom prst="rect">
             <a:avLst/>
@@ -4984,7 +4984,7 @@
         <p:spPr>
           <a:xfrm>
             <a:off x="4617541" y="6815435"/>
-            <a:ext cx="1827600" cy="360313"/>
+            <a:ext cx="1889802" cy="360313"/>
           </a:xfrm>
           <a:prstGeom prst="rect">
             <a:avLst/>
@@ -5025,7 +5025,7 @@
         <p:spPr>
           <a:xfrm>
             <a:off x="4617541" y="7207746"/>
-            <a:ext cx="1827600" cy="122486"/>
+            <a:ext cx="1889802" cy="122486"/>
           </a:xfrm>
           <a:prstGeom prst="rect">
             <a:avLst/>
@@ -5178,7 +5178,7 @@
         <p:spPr>
           <a:xfrm>
             <a:off x="7708255" y="178743"/>
-            <a:ext cx="1112029" cy="329803"/>
+            <a:ext cx="1153388" cy="329803"/>
           </a:xfrm>
           <a:prstGeom prst="rect">
             <a:avLst/>
@@ -5233,7 +5233,7 @@
         <p:spPr>
           <a:xfrm>
             <a:off x="7708255" y="522238"/>
-            <a:ext cx="1112029" cy="140196"/>
+            <a:ext cx="1153388" cy="140196"/>
           </a:xfrm>
           <a:prstGeom prst="rect">
             <a:avLst/>
@@ -5296,7 +5296,7 @@
         <p:spPr>
           <a:xfrm>
             <a:off x="6885384" y="2048024"/>
-            <a:ext cx="3023592" cy="548580"/>
+            <a:ext cx="3120628" cy="548580"/>
           </a:xfrm>
           <a:prstGeom prst="rect">
             <a:avLst/>
@@ -5351,7 +5351,7 @@
         <p:spPr>
           <a:xfrm>
             <a:off x="6885384" y="2678757"/>
-            <a:ext cx="3023592" cy="319980"/>
+            <a:ext cx="3120628" cy="319980"/>
           </a:xfrm>
           <a:prstGeom prst="rect">
             <a:avLst/>
@@ -5390,7 +5390,7 @@
         <p:spPr>
           <a:xfrm>
             <a:off x="6885384" y="3167658"/>
-            <a:ext cx="3023592" cy="484882"/>
+            <a:ext cx="3120628" cy="484882"/>
           </a:xfrm>
           <a:prstGeom prst="rect">
             <a:avLst/>
@@ -5447,7 +5447,7 @@
         <p:spPr>
           <a:xfrm>
             <a:off x="6885384" y="3707309"/>
-            <a:ext cx="3023592" cy="735955"/>
+            <a:ext cx="3120628" cy="735955"/>
           </a:xfrm>
           <a:prstGeom prst="rect">
             <a:avLst/>
@@ -5510,7 +5510,7 @@
         <p:spPr>
           <a:xfrm>
             <a:off x="6885384" y="4900166"/>
-            <a:ext cx="699671" cy="91232"/>
+            <a:ext cx="729020" cy="91232"/>
           </a:xfrm>
           <a:prstGeom prst="rect">
             <a:avLst/>
@@ -5573,7 +5573,7 @@
         <p:spPr>
           <a:xfrm>
             <a:off x="7637562" y="4900166"/>
-            <a:ext cx="699671" cy="91232"/>
+            <a:ext cx="729020" cy="91232"/>
           </a:xfrm>
           <a:prstGeom prst="rect">
             <a:avLst/>
@@ -5636,7 +5636,7 @@
         <p:spPr>
           <a:xfrm>
             <a:off x="8389739" y="4900166"/>
-            <a:ext cx="699671" cy="91232"/>
+            <a:ext cx="729020" cy="91232"/>
           </a:xfrm>
           <a:prstGeom prst="rect">
             <a:avLst/>
@@ -5699,7 +5699,7 @@
         <p:spPr>
           <a:xfrm>
             <a:off x="9141916" y="4900166"/>
-            <a:ext cx="699671" cy="91232"/>
+            <a:ext cx="729020" cy="91232"/>
           </a:xfrm>
           <a:prstGeom prst="rect">
             <a:avLst/>
@@ -5790,7 +5790,7 @@
         <p:spPr>
           <a:xfrm>
             <a:off x="6885384" y="5538936"/>
-            <a:ext cx="3023592" cy="215950"/>
+            <a:ext cx="3120628" cy="215950"/>
           </a:xfrm>
           <a:prstGeom prst="rect">
             <a:avLst/>
@@ -5829,7 +5829,7 @@
         <p:spPr>
           <a:xfrm>
             <a:off x="6885384" y="5786884"/>
-            <a:ext cx="3023592" cy="124271"/>
+            <a:ext cx="3120628" cy="124271"/>
           </a:xfrm>
           <a:prstGeom prst="rect">
             <a:avLst/>
@@ -5916,7 +5916,7 @@
         <p:spPr>
           <a:xfrm>
             <a:off x="6885384" y="6030218"/>
-            <a:ext cx="3023592" cy="215950"/>
+            <a:ext cx="3120628" cy="215950"/>
           </a:xfrm>
           <a:prstGeom prst="rect">
             <a:avLst/>
@@ -5955,7 +5955,7 @@
         <p:spPr>
           <a:xfrm>
             <a:off x="6885384" y="6278166"/>
-            <a:ext cx="3023592" cy="124271"/>
+            <a:ext cx="3120628" cy="124271"/>
           </a:xfrm>
           <a:prstGeom prst="rect">
             <a:avLst/>
@@ -6042,7 +6042,7 @@
         <p:spPr>
           <a:xfrm>
             <a:off x="6885384" y="6521500"/>
-            <a:ext cx="3023592" cy="215950"/>
+            <a:ext cx="3120628" cy="215950"/>
           </a:xfrm>
           <a:prstGeom prst="rect">
             <a:avLst/>
@@ -6081,7 +6081,7 @@
         <p:spPr>
           <a:xfrm>
             <a:off x="6885384" y="6769447"/>
-            <a:ext cx="3023592" cy="124271"/>
+            <a:ext cx="3120628" cy="124271"/>
           </a:xfrm>
           <a:prstGeom prst="rect">
             <a:avLst/>
@@ -6122,7 +6122,7 @@
         <p:spPr>
           <a:xfrm>
             <a:off x="6885384" y="7021711"/>
-            <a:ext cx="3023592" cy="494705"/>
+            <a:ext cx="3120628" cy="494705"/>
           </a:xfrm>
           <a:prstGeom prst="rect">
             <a:avLst/>
@@ -6305,7 +6305,7 @@
         <p:spPr>
           <a:xfrm>
             <a:off x="255984" y="260152"/>
-            <a:ext cx="3023592" cy="112068"/>
+            <a:ext cx="3120628" cy="112068"/>
           </a:xfrm>
           <a:prstGeom prst="rect">
             <a:avLst/>
@@ -6346,7 +6346,7 @@
         <p:spPr>
           <a:xfrm>
             <a:off x="255984" y="422374"/>
-            <a:ext cx="3023592" cy="373261"/>
+            <a:ext cx="3120628" cy="373261"/>
           </a:xfrm>
           <a:prstGeom prst="rect">
             <a:avLst/>
@@ -6433,7 +6433,7 @@
         <p:spPr>
           <a:xfrm>
             <a:off x="237679" y="2025253"/>
-            <a:ext cx="3042447" cy="107156"/>
+            <a:ext cx="3140032" cy="107156"/>
           </a:xfrm>
           <a:prstGeom prst="rect">
             <a:avLst/>
@@ -6474,7 +6474,7 @@
         <p:spPr>
           <a:xfrm>
             <a:off x="255984" y="2328714"/>
-            <a:ext cx="3023592" cy="323255"/>
+            <a:ext cx="3120628" cy="323255"/>
           </a:xfrm>
           <a:prstGeom prst="rect">
             <a:avLst/>
@@ -6513,7 +6513,7 @@
         <p:spPr>
           <a:xfrm>
             <a:off x="255984" y="2706737"/>
-            <a:ext cx="3023592" cy="441573"/>
+            <a:ext cx="3120628" cy="441573"/>
           </a:xfrm>
           <a:prstGeom prst="rect">
             <a:avLst/>
@@ -6552,7 +6552,7 @@
         <p:spPr>
           <a:xfrm>
             <a:off x="255984" y="3203079"/>
-            <a:ext cx="3023592" cy="294382"/>
+            <a:ext cx="3120628" cy="294382"/>
           </a:xfrm>
           <a:prstGeom prst="rect">
             <a:avLst/>
@@ -6781,7 +6781,7 @@
         <p:spPr>
           <a:xfrm>
             <a:off x="635943" y="4608016"/>
-            <a:ext cx="2069497" cy="127992"/>
+            <a:ext cx="2138744" cy="127992"/>
           </a:xfrm>
           <a:prstGeom prst="rect">
             <a:avLst/>
@@ -6820,7 +6820,7 @@
         <p:spPr>
           <a:xfrm>
             <a:off x="393799" y="4790926"/>
-            <a:ext cx="2759315" cy="441573"/>
+            <a:ext cx="2848654" cy="441573"/>
           </a:xfrm>
           <a:prstGeom prst="rect">
             <a:avLst/>
@@ -6883,7 +6883,7 @@
         <p:spPr>
           <a:xfrm>
             <a:off x="1417141" y="6122194"/>
-            <a:ext cx="1827600" cy="264914"/>
+            <a:ext cx="1889802" cy="264914"/>
           </a:xfrm>
           <a:prstGeom prst="rect">
             <a:avLst/>
@@ -6922,7 +6922,7 @@
         <p:spPr>
           <a:xfrm>
             <a:off x="1417141" y="6419106"/>
-            <a:ext cx="1827600" cy="600521"/>
+            <a:ext cx="1889802" cy="600521"/>
           </a:xfrm>
           <a:prstGeom prst="rect">
             <a:avLst/>
@@ -6963,7 +6963,7 @@
         <p:spPr>
           <a:xfrm>
             <a:off x="1417141" y="7051625"/>
-            <a:ext cx="1827600" cy="122486"/>
+            <a:ext cx="1889802" cy="122486"/>
           </a:xfrm>
           <a:prstGeom prst="rect">
             <a:avLst/>
@@ -7004,7 +7004,7 @@
         <p:spPr>
           <a:xfrm>
             <a:off x="255984" y="7302103"/>
-            <a:ext cx="3023592" cy="214312"/>
+            <a:ext cx="3120628" cy="214312"/>
           </a:xfrm>
           <a:prstGeom prst="rect">
             <a:avLst/>
@@ -7141,7 +7141,7 @@
         <p:spPr>
           <a:xfrm>
             <a:off x="3684984" y="260152"/>
-            <a:ext cx="3023592" cy="112068"/>
+            <a:ext cx="3120628" cy="112068"/>
           </a:xfrm>
           <a:prstGeom prst="rect">
             <a:avLst/>
@@ -7182,7 +7182,7 @@
         <p:spPr>
           <a:xfrm>
             <a:off x="3684984" y="422374"/>
-            <a:ext cx="3023592" cy="373261"/>
+            <a:ext cx="3120628" cy="373261"/>
           </a:xfrm>
           <a:prstGeom prst="rect">
             <a:avLst/>
@@ -7261,7 +7261,7 @@
         <p:spPr>
           <a:xfrm>
             <a:off x="3684984" y="2025253"/>
-            <a:ext cx="3023592" cy="107156"/>
+            <a:ext cx="3120628" cy="107156"/>
           </a:xfrm>
           <a:prstGeom prst="rect">
             <a:avLst/>
@@ -7300,7 +7300,7 @@
         <p:spPr>
           <a:xfrm>
             <a:off x="3684984" y="2328714"/>
-            <a:ext cx="3023592" cy="646509"/>
+            <a:ext cx="3120628" cy="646509"/>
           </a:xfrm>
           <a:prstGeom prst="rect">
             <a:avLst/>
@@ -7339,7 +7339,7 @@
         <p:spPr>
           <a:xfrm>
             <a:off x="3684984" y="3116759"/>
-            <a:ext cx="3023592" cy="127992"/>
+            <a:ext cx="3120628" cy="127992"/>
           </a:xfrm>
           <a:prstGeom prst="rect">
             <a:avLst/>
@@ -7402,7 +7402,7 @@
         <p:spPr>
           <a:xfrm>
             <a:off x="3918049" y="3276749"/>
-            <a:ext cx="2783535" cy="313432"/>
+            <a:ext cx="2873579" cy="313432"/>
           </a:xfrm>
           <a:prstGeom prst="rect">
             <a:avLst/>
@@ -7474,7 +7474,7 @@
         <p:spPr>
           <a:xfrm>
             <a:off x="3918049" y="3617565"/>
-            <a:ext cx="2783535" cy="313432"/>
+            <a:ext cx="2873579" cy="313432"/>
           </a:xfrm>
           <a:prstGeom prst="rect">
             <a:avLst/>
@@ -7546,7 +7546,7 @@
         <p:spPr>
           <a:xfrm>
             <a:off x="3918049" y="3958382"/>
-            <a:ext cx="2783535" cy="465386"/>
+            <a:ext cx="2873579" cy="465386"/>
           </a:xfrm>
           <a:prstGeom prst="rect">
             <a:avLst/>
@@ -7618,7 +7618,7 @@
         <p:spPr>
           <a:xfrm>
             <a:off x="3684984" y="5438477"/>
-            <a:ext cx="3023592" cy="321469"/>
+            <a:ext cx="3120628" cy="321469"/>
           </a:xfrm>
           <a:prstGeom prst="rect">
             <a:avLst/>
@@ -7657,7 +7657,7 @@
         <p:spPr>
           <a:xfrm>
             <a:off x="3684984" y="5901482"/>
-            <a:ext cx="3023592" cy="127992"/>
+            <a:ext cx="3120628" cy="127992"/>
           </a:xfrm>
           <a:prstGeom prst="rect">
             <a:avLst/>
@@ -7720,7 +7720,7 @@
         <p:spPr>
           <a:xfrm>
             <a:off x="3684984" y="6463605"/>
-            <a:ext cx="699671" cy="182463"/>
+            <a:ext cx="729020" cy="182463"/>
           </a:xfrm>
           <a:prstGeom prst="rect">
             <a:avLst/>
@@ -7799,7 +7799,7 @@
         <p:spPr>
           <a:xfrm>
             <a:off x="4437162" y="6463605"/>
-            <a:ext cx="699671" cy="273695"/>
+            <a:ext cx="729020" cy="273695"/>
           </a:xfrm>
           <a:prstGeom prst="rect">
             <a:avLst/>
@@ -7894,7 +7894,7 @@
         <p:spPr>
           <a:xfrm>
             <a:off x="5189339" y="6463605"/>
-            <a:ext cx="699671" cy="273695"/>
+            <a:ext cx="729020" cy="273695"/>
           </a:xfrm>
           <a:prstGeom prst="rect">
             <a:avLst/>
@@ -7989,7 +7989,7 @@
         <p:spPr>
           <a:xfrm>
             <a:off x="5941516" y="6463605"/>
-            <a:ext cx="699671" cy="273695"/>
+            <a:ext cx="729020" cy="273695"/>
           </a:xfrm>
           <a:prstGeom prst="rect">
             <a:avLst/>
@@ -8150,7 +8150,7 @@
         <p:spPr>
           <a:xfrm>
             <a:off x="3822799" y="6933754"/>
-            <a:ext cx="2759315" cy="320873"/>
+            <a:ext cx="2848654" cy="320873"/>
           </a:xfrm>
           <a:prstGeom prst="rect">
             <a:avLst/>
@@ -8285,7 +8285,7 @@
         <p:spPr>
           <a:xfrm>
             <a:off x="7113984" y="260152"/>
-            <a:ext cx="2788134" cy="112068"/>
+            <a:ext cx="2878312" cy="112068"/>
           </a:xfrm>
           <a:prstGeom prst="rect">
             <a:avLst/>
@@ -8326,7 +8326,7 @@
         <p:spPr>
           <a:xfrm>
             <a:off x="7113984" y="422374"/>
-            <a:ext cx="2788134" cy="373261"/>
+            <a:ext cx="2878312" cy="373261"/>
           </a:xfrm>
           <a:prstGeom prst="rect">
             <a:avLst/>
@@ -8389,7 +8389,7 @@
         <p:spPr>
           <a:xfrm>
             <a:off x="7113984" y="2025253"/>
-            <a:ext cx="2806989" cy="107156"/>
+            <a:ext cx="2897716" cy="107156"/>
           </a:xfrm>
           <a:prstGeom prst="rect">
             <a:avLst/>
@@ -8428,7 +8428,7 @@
         <p:spPr>
           <a:xfrm>
             <a:off x="7113984" y="2328714"/>
-            <a:ext cx="2788134" cy="646509"/>
+            <a:ext cx="2878312" cy="646509"/>
           </a:xfrm>
           <a:prstGeom prst="rect">
             <a:avLst/>
@@ -8491,7 +8491,7 @@
         <p:spPr>
           <a:xfrm>
             <a:off x="7356128" y="3052762"/>
-            <a:ext cx="813721" cy="127992"/>
+            <a:ext cx="846392" cy="127992"/>
           </a:xfrm>
           <a:prstGeom prst="rect">
             <a:avLst/>
@@ -8530,7 +8530,7 @@
         <p:spPr>
           <a:xfrm>
             <a:off x="7113984" y="3235672"/>
-            <a:ext cx="2788134" cy="668238"/>
+            <a:ext cx="2878312" cy="668238"/>
           </a:xfrm>
           <a:prstGeom prst="rect">
             <a:avLst/>
@@ -8639,7 +8639,7 @@
         <p:spPr>
           <a:xfrm>
             <a:off x="7356128" y="4045744"/>
-            <a:ext cx="892207" cy="127992"/>
+            <a:ext cx="927164" cy="127992"/>
           </a:xfrm>
           <a:prstGeom prst="rect">
             <a:avLst/>
@@ -8678,7 +8678,7 @@
         <p:spPr>
           <a:xfrm>
             <a:off x="7113984" y="4228654"/>
-            <a:ext cx="2788134" cy="534591"/>
+            <a:ext cx="2878312" cy="534591"/>
           </a:xfrm>
           <a:prstGeom prst="rect">
             <a:avLst/>
@@ -8787,7 +8787,7 @@
         <p:spPr>
           <a:xfrm>
             <a:off x="7356128" y="4905077"/>
-            <a:ext cx="921639" cy="127992"/>
+            <a:ext cx="957453" cy="127992"/>
           </a:xfrm>
           <a:prstGeom prst="rect">
             <a:avLst/>
@@ -8826,7 +8826,7 @@
         <p:spPr>
           <a:xfrm>
             <a:off x="7113984" y="5087987"/>
-            <a:ext cx="2788134" cy="668238"/>
+            <a:ext cx="2878312" cy="668238"/>
           </a:xfrm>
           <a:prstGeom prst="rect">
             <a:avLst/>
@@ -8935,7 +8935,7 @@
         <p:spPr>
           <a:xfrm>
             <a:off x="7356128" y="5898059"/>
-            <a:ext cx="852964" cy="127992"/>
+            <a:ext cx="886778" cy="127992"/>
           </a:xfrm>
           <a:prstGeom prst="rect">
             <a:avLst/>
@@ -8974,7 +8974,7 @@
         <p:spPr>
           <a:xfrm>
             <a:off x="7113984" y="6080968"/>
-            <a:ext cx="2788134" cy="400943"/>
+            <a:ext cx="2878312" cy="400943"/>
           </a:xfrm>
           <a:prstGeom prst="rect">
             <a:avLst/>
@@ -9037,7 +9037,7 @@
         <p:spPr>
           <a:xfrm>
             <a:off x="8275141" y="6686104"/>
-            <a:ext cx="1592142" cy="132457"/>
+            <a:ext cx="1647486" cy="132457"/>
           </a:xfrm>
           <a:prstGeom prst="rect">
             <a:avLst/>
@@ -9076,7 +9076,7 @@
         <p:spPr>
           <a:xfrm>
             <a:off x="8275141" y="6850559"/>
-            <a:ext cx="1592142" cy="360313"/>
+            <a:ext cx="1647486" cy="360313"/>
           </a:xfrm>
           <a:prstGeom prst="rect">
             <a:avLst/>
@@ -9133,7 +9133,7 @@
         <p:spPr>
           <a:xfrm>
             <a:off x="8275141" y="7242870"/>
-            <a:ext cx="1592142" cy="122486"/>
+            <a:ext cx="1647486" cy="122486"/>
           </a:xfrm>
           <a:prstGeom prst="rect">
             <a:avLst/>

</xml_diff>